<commit_message>
Fix deck corruption: chart point colors out of order and undeclared axis ids
Co-Authored-By: Claude Opus 5.5 <noreply@anthropic.com>
Claude-Session: https://claude.ai/code/session_01QYZvaKtS17FJe9xeABzS7D
</commit_message>
<xml_diff>
--- a/business-model-lab/saidas/Beyond-Tower-Sharing.pptx
+++ b/business-model-lab/saidas/Beyond-Tower-Sharing.pptx
@@ -127,13 +127,13 @@
   <p:extLst>
     <p:ext uri="{521415D9-36F7-43E2-AB2F-B90AF26B5E84}">
       <p14:sectionLst xmlns:p14="http://schemas.microsoft.com/office/powerpoint/2010/main">
-        <p14:section name="Opening" id="{0297db0c-5c55-bf95-50a3-69f65371e8b8}">
+        <p14:section name="Opening" id="{b4b08405-2b04-6d86-0876-63653fdc68ae}">
           <p14:sldIdLst>
             <p14:sldId id="256"/>
             <p14:sldId id="257"/>
           </p14:sldIdLst>
         </p14:section>
-        <p14:section name="Why tower growth is slowing" id="{7bd90fa8-c175-d9a4-856e-ecb6a5785d08}">
+        <p14:section name="Why tower growth is slowing" id="{3e68d749-203b-7ad9-d480-ba1bee58c538}">
           <p14:sldIdLst>
             <p14:sldId id="258"/>
             <p14:sldId id="259"/>
@@ -143,14 +143,14 @@
             <p14:sldId id="263"/>
           </p14:sldIdLst>
         </p14:section>
-        <p14:section name="The growth ambition" id="{eca51c85-cf5a-cb27-2dd2-f2bf991a93be}">
+        <p14:section name="The growth ambition" id="{eb0cb658-02ca-0f3b-487f-c15111df340e}">
           <p14:sldIdLst>
             <p14:sldId id="264"/>
             <p14:sldId id="265"/>
             <p14:sldId id="266"/>
           </p14:sldIdLst>
         </p14:section>
-        <p14:section name="Ideas with transformative potential" id="{a20f12eb-4028-be8d-5005-b1de8155c15b}">
+        <p14:section name="Ideas with transformative potential" id="{9c3295ab-9a6e-a89b-a4df-294c651d5db1}">
           <p14:sldIdLst>
             <p14:sldId id="267"/>
             <p14:sldId id="268"/>
@@ -161,7 +161,7 @@
             <p14:sldId id="273"/>
           </p14:sldIdLst>
         </p14:section>
-        <p14:section name="Next steps" id="{c515f1d7-255b-45e4-f47a-1a6ec07ecb8c}">
+        <p14:section name="Next steps" id="{f4def07f-be2d-7d71-085c-9ba351aa6fad}">
           <p14:sldIdLst>
             <p14:sldId id="274"/>
             <p14:sldId id="275"/>
@@ -329,7 +329,6 @@
         <c:overlap val="0"/>
         <c:axId val="2094734554"/>
         <c:axId val="2094734552"/>
-        <c:axId val="2094734556"/>
       </c:barChart>
       <c:catAx>
         <c:axId val="2094734554"/>
@@ -472,7 +471,7 @@
                 </a:solidFill>
                 <a:latin typeface="+mn-lt"/>
               </a:rPr>
-              <a:t>Share price change since end of 2022 (%)</a:t>
+              <a:t>Tower REIT share price change since end of 2022 (%)</a:t>
             </a:r>
           </a:p>
         </c:rich>
@@ -503,7 +502,7 @@
           </c:tx>
           <c:spPr>
             <a:solidFill>
-              <a:srgbClr val="2A9D8F"/>
+              <a:srgbClr val="C8553D"/>
             </a:solidFill>
             <a:effectLst/>
           </c:spPr>
@@ -532,66 +531,19 @@
             <c:showBubbleSize val="0"/>
             <c:showLeaderLines val="0"/>
           </c:dLbls>
-          <c:dPt>
-            <c:idx val="0"/>
-            <c:invertIfNegative val="0"/>
-            <c:bubble3D val="0"/>
-            <c:spPr>
-              <a:solidFill>
-                <a:srgbClr val="2A9D8F"/>
-              </a:solidFill>
-              <a:effectLst/>
-            </c:spPr>
-          </c:dPt>
-          <c:dPt>
-            <c:idx val="1"/>
-            <c:invertIfNegative val="0"/>
-            <c:bubble3D val="0"/>
-            <c:spPr>
-              <a:solidFill>
-                <a:srgbClr val="C8553D"/>
-              </a:solidFill>
-              <a:effectLst/>
-            </c:spPr>
-          </c:dPt>
-          <c:dPt>
-            <c:idx val="2"/>
-            <c:invertIfNegative val="0"/>
-            <c:bubble3D val="0"/>
-            <c:spPr>
-              <a:solidFill>
-                <a:srgbClr val="C8553D"/>
-              </a:solidFill>
-              <a:effectLst/>
-            </c:spPr>
-          </c:dPt>
-          <c:dPt>
-            <c:idx val="3"/>
-            <c:invertIfNegative val="0"/>
-            <c:bubble3D val="0"/>
-            <c:spPr>
-              <a:solidFill>
-                <a:srgbClr val="C8553D"/>
-              </a:solidFill>
-              <a:effectLst/>
-            </c:spPr>
-          </c:dPt>
           <c:cat>
             <c:multiLvlStrRef>
-              <c:f>Sheet1!$A$2:$A$5</c:f>
+              <c:f>Sheet1!$A$2:$A$4</c:f>
               <c:multiLvlStrCache>
-                <c:ptCount val="4"/>
+                <c:ptCount val="3"/>
                 <c:lvl>
                   <c:pt idx="0">
-                    <c:v>S&amp;P 500</c:v>
+                    <c:v>American Tower</c:v>
                   </c:pt>
                   <c:pt idx="1">
-                    <c:v>American Tower</c:v>
+                    <c:v>Crown Castle</c:v>
                   </c:pt>
                   <c:pt idx="2">
-                    <c:v>Crown Castle</c:v>
-                  </c:pt>
-                  <c:pt idx="3">
                     <c:v>SBA</c:v>
                   </c:pt>
                 </c:lvl>
@@ -600,20 +552,17 @@
           </c:cat>
           <c:val>
             <c:numRef>
-              <c:f>Sheet1!$B$2:$B$5</c:f>
+              <c:f>Sheet1!$B$2:$B$4</c:f>
               <c:numCache>
                 <c:formatCode>General</c:formatCode>
-                <c:ptCount val="4"/>
+                <c:ptCount val="3"/>
                 <c:pt idx="0">
-                  <c:v>49</c:v>
+                  <c:v>-2</c:v>
                 </c:pt>
                 <c:pt idx="1">
-                  <c:v>-2</c:v>
+                  <c:v>-22</c:v>
                 </c:pt>
                 <c:pt idx="2">
-                  <c:v>-22</c:v>
-                </c:pt>
-                <c:pt idx="3">
                   <c:v>-29</c:v>
                 </c:pt>
               </c:numCache>
@@ -648,7 +597,6 @@
         <c:overlap val="0"/>
         <c:axId val="2094734554"/>
         <c:axId val="2094734552"/>
-        <c:axId val="2094734556"/>
       </c:barChart>
       <c:catAx>
         <c:axId val="2094734554"/>
@@ -660,7 +608,7 @@
         <c:numFmt formatCode="General" sourceLinked="1"/>
         <c:majorTickMark val="out"/>
         <c:minorTickMark val="none"/>
-        <c:tickLblPos val="low"/>
+        <c:tickLblPos val="high"/>
         <c:spPr>
           <a:ln w="12700" cap="flat">
             <a:solidFill>
@@ -1012,7 +960,6 @@
         <c:overlap val="0"/>
         <c:axId val="2094734554"/>
         <c:axId val="2094734552"/>
-        <c:axId val="2094734556"/>
       </c:barChart>
       <c:catAx>
         <c:axId val="2094734554"/>
@@ -15381,7 +15328,7 @@
         </p:nvGraphicFramePr>
         <p:xfrm>
           <a:off x="548640" y="1371600"/>
-          <a:ext cx="6583680" cy="4480560"/>
+          <a:ext cx="6583680" cy="3383280"/>
         </p:xfrm>
         <a:graphic xmlns:a="http://schemas.openxmlformats.org/drawingml/2006/main">
           <a:graphicData uri="http://schemas.openxmlformats.org/drawingml/2006/chart">
@@ -15391,18 +15338,18 @@
       </p:graphicFrame>
       <p:sp>
         <p:nvSpPr>
-          <p:cNvPr id="4" name="Stat card 1"/>
+          <p:cNvPr id="4" name="S&amp;P comparison card"/>
           <p:cNvSpPr/>
           <p:nvPr/>
         </p:nvSpPr>
         <p:spPr>
           <a:xfrm>
-            <a:off x="7498080" y="1371600"/>
-            <a:ext cx="4114800" cy="1325880"/>
+            <a:off x="548640" y="4892040"/>
+            <a:ext cx="6583680" cy="1005840"/>
           </a:xfrm>
           <a:prstGeom prst="roundRect">
             <a:avLst>
-              <a:gd name="adj" fmla="val 8276"/>
+              <a:gd name="adj" fmla="val 10909"/>
             </a:avLst>
           </a:prstGeom>
           <a:solidFill>
@@ -15431,34 +15378,34 @@
         </p:nvSpPr>
         <p:spPr>
           <a:xfrm>
-            <a:off x="7726680" y="1508760"/>
-            <a:ext cx="3657600" cy="548640"/>
-          </a:xfrm>
-          <a:prstGeom prst="rect">
-            <a:avLst/>
-          </a:prstGeom>
-          <a:noFill/>
-          <a:ln/>
-        </p:spPr>
-        <p:txBody>
-          <a:bodyPr wrap="square" lIns="0" tIns="0" rIns="0" bIns="0" rtlCol="0" anchor="t"/>
+            <a:off x="822960" y="4983480"/>
+            <a:ext cx="1645920" cy="822960"/>
+          </a:xfrm>
+          <a:prstGeom prst="rect">
+            <a:avLst/>
+          </a:prstGeom>
+          <a:noFill/>
+          <a:ln/>
+        </p:spPr>
+        <p:txBody>
+          <a:bodyPr wrap="square" lIns="0" tIns="0" rIns="0" bIns="0" rtlCol="0" anchor="ctr"/>
           <a:lstStyle/>
           <a:p>
             <a:pPr indent="0" marL="0">
               <a:buNone/>
             </a:pPr>
             <a:r>
-              <a:rPr lang="en-US" sz="3000" b="1" dirty="0">
-                <a:solidFill>
-                  <a:schemeClr val="accent4"/>
+              <a:rPr lang="en-US" sz="3200" b="1" dirty="0">
+                <a:solidFill>
+                  <a:schemeClr val="accent2"/>
                 </a:solidFill>
                 <a:latin typeface="Cambria" pitchFamily="34" charset="0"/>
                 <a:ea typeface="Cambria" pitchFamily="34" charset="-122"/>
                 <a:cs typeface="Cambria" pitchFamily="34" charset="-120"/>
               </a:rPr>
-              <a:t>~4% to 0.5%</a:t>
-            </a:r>
-            <a:endParaRPr lang="en-US" sz="3000" dirty="0"/>
+              <a:t>+49%</a:t>
+            </a:r>
+            <a:endParaRPr lang="en-US" sz="3200" dirty="0"/>
           </a:p>
         </p:txBody>
       </p:sp>
@@ -15470,43 +15417,43 @@
         </p:nvSpPr>
         <p:spPr>
           <a:xfrm>
-            <a:off x="7726680" y="2103120"/>
-            <a:ext cx="3657600" cy="548640"/>
-          </a:xfrm>
-          <a:prstGeom prst="rect">
-            <a:avLst/>
-          </a:prstGeom>
-          <a:noFill/>
-          <a:ln/>
-        </p:spPr>
-        <p:txBody>
-          <a:bodyPr wrap="square" lIns="0" tIns="0" rIns="0" bIns="0" rtlCol="0" anchor="t"/>
+            <a:off x="2560320" y="4983480"/>
+            <a:ext cx="4389120" cy="822960"/>
+          </a:xfrm>
+          <a:prstGeom prst="rect">
+            <a:avLst/>
+          </a:prstGeom>
+          <a:noFill/>
+          <a:ln/>
+        </p:spPr>
+        <p:txBody>
+          <a:bodyPr wrap="square" lIns="0" tIns="0" rIns="0" bIns="0" rtlCol="0" anchor="ctr"/>
           <a:lstStyle/>
           <a:p>
             <a:pPr indent="0" marL="0">
               <a:buNone/>
             </a:pPr>
             <a:r>
-              <a:rPr lang="en-US" sz="1300" dirty="0">
+              <a:rPr lang="en-US" sz="1400" dirty="0">
                 <a:solidFill>
                   <a:schemeClr val="tx1"/>
                 </a:solidFill>
               </a:rPr>
-              <a:t>American Tower 2026 organic growth, before and after removing DISH leases</a:t>
-            </a:r>
-            <a:endParaRPr lang="en-US" sz="1300" dirty="0"/>
-          </a:p>
-        </p:txBody>
-      </p:sp>
-      <p:sp>
-        <p:nvSpPr>
-          <p:cNvPr id="7" name="Stat card 2"/>
+              <a:t>S&amp;P 500 over the same period: the tower REITs lagged the market by 50 to 78 points</a:t>
+            </a:r>
+            <a:endParaRPr lang="en-US" sz="1400" dirty="0"/>
+          </a:p>
+        </p:txBody>
+      </p:sp>
+      <p:sp>
+        <p:nvSpPr>
+          <p:cNvPr id="7" name="Stat card 1"/>
           <p:cNvSpPr/>
           <p:nvPr/>
         </p:nvSpPr>
         <p:spPr>
           <a:xfrm>
-            <a:off x="7498080" y="2880360"/>
+            <a:off x="7498080" y="1371600"/>
             <a:ext cx="4114800" cy="1325880"/>
           </a:xfrm>
           <a:prstGeom prst="roundRect">
@@ -15540,7 +15487,7 @@
         </p:nvSpPr>
         <p:spPr>
           <a:xfrm>
-            <a:off x="7726680" y="3017520"/>
+            <a:off x="7726680" y="1508760"/>
             <a:ext cx="3657600" cy="548640"/>
           </a:xfrm>
           <a:prstGeom prst="rect">
@@ -15565,7 +15512,7 @@
                 <a:ea typeface="Cambria" pitchFamily="34" charset="-122"/>
                 <a:cs typeface="Cambria" pitchFamily="34" charset="-120"/>
               </a:rPr>
-              <a:t>US$ 220M</a:t>
+              <a:t>~4% to 0.5%</a:t>
             </a:r>
             <a:endParaRPr lang="en-US" sz="3000" dirty="0"/>
           </a:p>
@@ -15579,7 +15526,7 @@
         </p:nvSpPr>
         <p:spPr>
           <a:xfrm>
-            <a:off x="7726680" y="3611880"/>
+            <a:off x="7726680" y="2103120"/>
             <a:ext cx="3657600" cy="548640"/>
           </a:xfrm>
           <a:prstGeom prst="rect">
@@ -15601,7 +15548,7 @@
                   <a:schemeClr val="tx1"/>
                 </a:solidFill>
               </a:rPr>
-              <a:t>Crown Castle 2026 revenue hit from DISH terminations</a:t>
+              <a:t>American Tower 2026 organic growth, before and after removing DISH leases</a:t>
             </a:r>
             <a:endParaRPr lang="en-US" sz="1300" dirty="0"/>
           </a:p>
@@ -15609,13 +15556,13 @@
       </p:sp>
       <p:sp>
         <p:nvSpPr>
-          <p:cNvPr id="10" name="Stat card 3"/>
+          <p:cNvPr id="10" name="Stat card 2"/>
           <p:cNvSpPr/>
           <p:nvPr/>
         </p:nvSpPr>
         <p:spPr>
           <a:xfrm>
-            <a:off x="7498080" y="4389120"/>
+            <a:off x="7498080" y="2880360"/>
             <a:ext cx="4114800" cy="1325880"/>
           </a:xfrm>
           <a:prstGeom prst="roundRect">
@@ -15649,7 +15596,7 @@
         </p:nvSpPr>
         <p:spPr>
           <a:xfrm>
-            <a:off x="7726680" y="4526280"/>
+            <a:off x="7726680" y="3017520"/>
             <a:ext cx="3657600" cy="548640"/>
           </a:xfrm>
           <a:prstGeom prst="rect">
@@ -15674,7 +15621,7 @@
                 <a:ea typeface="Cambria" pitchFamily="34" charset="-122"/>
                 <a:cs typeface="Cambria" pitchFamily="34" charset="-120"/>
               </a:rPr>
-              <a:t>−2%</a:t>
+              <a:t>US$ 220M</a:t>
             </a:r>
             <a:endParaRPr lang="en-US" sz="3000" dirty="0"/>
           </a:p>
@@ -15688,6 +15635,115 @@
         </p:nvSpPr>
         <p:spPr>
           <a:xfrm>
+            <a:off x="7726680" y="3611880"/>
+            <a:ext cx="3657600" cy="548640"/>
+          </a:xfrm>
+          <a:prstGeom prst="rect">
+            <a:avLst/>
+          </a:prstGeom>
+          <a:noFill/>
+          <a:ln/>
+        </p:spPr>
+        <p:txBody>
+          <a:bodyPr wrap="square" lIns="0" tIns="0" rIns="0" bIns="0" rtlCol="0" anchor="t"/>
+          <a:lstStyle/>
+          <a:p>
+            <a:pPr indent="0" marL="0">
+              <a:buNone/>
+            </a:pPr>
+            <a:r>
+              <a:rPr lang="en-US" sz="1300" dirty="0">
+                <a:solidFill>
+                  <a:schemeClr val="tx1"/>
+                </a:solidFill>
+              </a:rPr>
+              <a:t>Crown Castle 2026 revenue hit from DISH terminations</a:t>
+            </a:r>
+            <a:endParaRPr lang="en-US" sz="1300" dirty="0"/>
+          </a:p>
+        </p:txBody>
+      </p:sp>
+      <p:sp>
+        <p:nvSpPr>
+          <p:cNvPr id="13" name="Stat card 3"/>
+          <p:cNvSpPr/>
+          <p:nvPr/>
+        </p:nvSpPr>
+        <p:spPr>
+          <a:xfrm>
+            <a:off x="7498080" y="4389120"/>
+            <a:ext cx="4114800" cy="1325880"/>
+          </a:xfrm>
+          <a:prstGeom prst="roundRect">
+            <a:avLst>
+              <a:gd name="adj" fmla="val 8276"/>
+            </a:avLst>
+          </a:prstGeom>
+          <a:solidFill>
+            <a:srgbClr val="EEF1F5"/>
+          </a:solidFill>
+          <a:ln w="12700">
+            <a:solidFill>
+              <a:srgbClr val="EEF1F5"/>
+            </a:solidFill>
+            <a:prstDash val="solid"/>
+          </a:ln>
+          <a:effectLst>
+            <a:outerShdw sx="100000" sy="100000" kx="0" ky="0" algn="bl" rotWithShape="0" blurRad="76200" dist="25400" dir="5400000">
+              <a:srgbClr val="9AA5B1">
+                <a:alpha val="25000"/>
+              </a:srgbClr>
+            </a:outerShdw>
+          </a:effectLst>
+        </p:spPr>
+      </p:sp>
+      <p:sp>
+        <p:nvSpPr>
+          <p:cNvPr id="14" name="Text 11"/>
+          <p:cNvSpPr txBox="1"/>
+          <p:nvPr/>
+        </p:nvSpPr>
+        <p:spPr>
+          <a:xfrm>
+            <a:off x="7726680" y="4526280"/>
+            <a:ext cx="3657600" cy="548640"/>
+          </a:xfrm>
+          <a:prstGeom prst="rect">
+            <a:avLst/>
+          </a:prstGeom>
+          <a:noFill/>
+          <a:ln/>
+        </p:spPr>
+        <p:txBody>
+          <a:bodyPr wrap="square" lIns="0" tIns="0" rIns="0" bIns="0" rtlCol="0" anchor="t"/>
+          <a:lstStyle/>
+          <a:p>
+            <a:pPr indent="0" marL="0">
+              <a:buNone/>
+            </a:pPr>
+            <a:r>
+              <a:rPr lang="en-US" sz="3000" b="1" dirty="0">
+                <a:solidFill>
+                  <a:schemeClr val="accent4"/>
+                </a:solidFill>
+                <a:latin typeface="Cambria" pitchFamily="34" charset="0"/>
+                <a:ea typeface="Cambria" pitchFamily="34" charset="-122"/>
+                <a:cs typeface="Cambria" pitchFamily="34" charset="-120"/>
+              </a:rPr>
+              <a:t>−2%</a:t>
+            </a:r>
+            <a:endParaRPr lang="en-US" sz="3000" dirty="0"/>
+          </a:p>
+        </p:txBody>
+      </p:sp>
+      <p:sp>
+        <p:nvSpPr>
+          <p:cNvPr id="15" name="Text 12"/>
+          <p:cNvSpPr txBox="1"/>
+          <p:nvPr/>
+        </p:nvSpPr>
+        <p:spPr>
+          <a:xfrm>
             <a:off x="7726680" y="5120640"/>
             <a:ext cx="3657600" cy="548640"/>
           </a:xfrm>
@@ -15718,7 +15774,7 @@
       </p:sp>
       <p:sp>
         <p:nvSpPr>
-          <p:cNvPr id="13" name="Text 10"/>
+          <p:cNvPr id="16" name="Text 13"/>
           <p:cNvSpPr txBox="1"/>
           <p:nvPr/>
         </p:nvSpPr>

</xml_diff>